<commit_message>
Update to latest run metrics (16001 steps): better T1/T2 + real hybrid T3
New self-eval numbers (artifacts/metrics.json + metrics_hybrid.json) across REPORT,
deck, READMEs, paper banner:
- Task 1: decoder Top-1 0.877 -> physics-rerank (submitted) 0.937; Top-5 1.000;
  MRR 0.97; next-operation accuracy 0.998.
- Task 2: block-level 0.94, 100% rule-valid, token 0.71, exact 0.28.
- Task 3 (physics hybrid, submitted): precision/recall/F1 = 1.000, rule-attribution
  0.972. Learned encoder ALONE is honestly degenerate (F1 0, AUC 0.49 ≈ chance,
  collapses to predicting valid) — reported openly; ROC-AUC sits at chance because the
  encoder's SCORE is uncalibrated (motivates the calibration next-step).
Deck rebuilt (8 slides). Direct numbers throughout.

Co-Authored-By: Claude Opus 4.8 <noreply@anthropic.com>
</commit_message>
<xml_diff>
--- a/tracks/industrial-infineon/solution/pitch/ProcSeq_Pitch.pptx
+++ b/tracks/industrial-infineon/solution/pitch/ProcSeq_Pitch.pptx
@@ -859,7 +859,7 @@
           <a:lstStyle/>
           <a:p>
             <a:r>
-              <a:t>35s. Real numbers, official scorer, held-out split, from the completed ProcSeq run. Task1: Top-5 perfect, Top-1 0.77, and 0.96 next-OPERATION accuracy → it learned function, not just names. Task2: block-level 0.92 and 100% rule-valid completions. Task3, be honest: the learned encoder alone is ~chance (AUC 0.61), so the physics hybrid gives the exact in-distribution verdict. Organizer hidden test + 4th-family OOD still pending.</a:t>
+              <a:t>35s. Real numbers, official scorer, held-out split, from the completed ProcSeq run. Task1: Top-5 perfect, Top-1 0.94 (hybrid), and 0.998 next-OPERATION accuracy → it learned function, not just names. Task2: block-level 0.94 and 100% rule-valid completions. Task3, be honest: the learned encoder alone is ~chance (AUC 0.49, collapses to all-valid), so the physics hybrid gives the exact verdict (F1 1.0, rule-attr 0.97). Hidden test + OOD pending.</a:t>
             </a:r>
           </a:p>
         </p:txBody>
@@ -929,7 +929,7 @@
           <a:lstStyle/>
           <a:p>
             <a:r>
-              <a:t>30s. The evidence it LEARNED, not memorized: 0.96 next-operation accuracy (right step type, not just a name); 100% rule-valid completions (the physics guarantee); and we're honest that the learned anomaly encoder is weak (AUC 0.61) so the hybrid carries Task 3. All held-out, official scorer; hidden test + OOD marked pending.</a:t>
+              <a:t>30s. The evidence it LEARNED, not memorized: 0.998 next-operation accuracy (right step type, not just a name); 100% rule-valid completions (the physics guarantee); and we're honest that the learned anomaly encoder is ~chance (AUC 0.49) so the hybrid carries Task 3. All held-out, official scorer; hidden test + OOD marked pending.</a:t>
             </a:r>
           </a:p>
         </p:txBody>
@@ -7267,7 +7267,7 @@
                           </a:solidFill>
                           <a:latin typeface="Consolas"/>
                         </a:rPr>
-                        <a:t>Top-5 1.000  ·  Top-1 0.772</a:t>
+                        <a:t>Top-1 0.937  ·  Top-5 1.000</a:t>
                       </a:r>
                     </a:p>
                   </a:txBody>
@@ -7290,7 +7290,7 @@
                           </a:solidFill>
                           <a:latin typeface="Consolas"/>
                         </a:rPr>
-                        <a:t>MRR 0.88</a:t>
+                        <a:t>MRR 0.97  (hybrid)</a:t>
                       </a:r>
                     </a:p>
                   </a:txBody>
@@ -7338,7 +7338,7 @@
                           </a:solidFill>
                           <a:latin typeface="Consolas"/>
                         </a:rPr>
-                        <a:t>Block-level 0.92  ·  100% rule-valid</a:t>
+                        <a:t>Block-level 0.94  ·  100% rule-valid</a:t>
                       </a:r>
                     </a:p>
                   </a:txBody>
@@ -7361,7 +7361,7 @@
                           </a:solidFill>
                           <a:latin typeface="Consolas"/>
                         </a:rPr>
-                        <a:t>token 0.57 · exact 0.14</a:t>
+                        <a:t>token 0.71 · exact 0.28</a:t>
                       </a:r>
                     </a:p>
                   </a:txBody>
@@ -7409,7 +7409,7 @@
                           </a:solidFill>
                           <a:latin typeface="Consolas"/>
                         </a:rPr>
-                        <a:t>Binary acc 1.000  (hybrid)</a:t>
+                        <a:t>F1 1.000  ·  rule-attr 0.972</a:t>
                       </a:r>
                     </a:p>
                   </a:txBody>
@@ -7432,7 +7432,7 @@
                           </a:solidFill>
                           <a:latin typeface="Consolas"/>
                         </a:rPr>
-                        <a:t>encoder alone AUC 0.61 (honest)</a:t>
+                        <a:t>encoder alone AUC 0.49 (honest)</a:t>
                       </a:r>
                     </a:p>
                   </a:txBody>
@@ -7480,7 +7480,7 @@
                           </a:solidFill>
                           <a:latin typeface="Consolas"/>
                         </a:rPr>
-                        <a:t>0.963 next-operation acc</a:t>
+                        <a:t>0.998 next-operation acc</a:t>
                       </a:r>
                     </a:p>
                   </a:txBody>
@@ -7585,7 +7585,7 @@
                 </a:solidFill>
                 <a:latin typeface="Consolas"/>
               </a:rPr>
-              <a:t>operation 96% of the time</a:t>
+              <a:t>operation 99.8% of the time</a:t>
             </a:r>
             <a:r>
               <a:rPr sz="1300" b="0">
@@ -7648,7 +7648,7 @@
                 </a:solidFill>
                 <a:latin typeface="Arial"/>
               </a:rPr>
-              <a:t>real numbers from the organizer's official scorer on a held-out self-eval split, from the completed ProcSeq Leonardo run (base, 16k steps). The learned anomaly encoder alone is weak (AUC 0.61) — the physics hybrid carries Task 3. Organizer hidden-test and 4th-family OOD are pending.</a:t>
+              <a:t>real numbers from the organizer's official scorer on a held-out self-eval split, from the completed ProcSeq Leonardo run (base, 16k steps). The learned anomaly encoder alone is ~chance (AUC 0.49) — the physics hybrid carries Task 3. Organizer hidden-test and 4th-family OOD are pending.</a:t>
             </a:r>
           </a:p>
         </p:txBody>
@@ -7932,7 +7932,7 @@
                 </a:solidFill>
                 <a:latin typeface="Arial"/>
               </a:rPr>
-              <a:t>0.963 next-OPERATION accuracy — it predicts the right kind of step (deposit / etch / clean), not just a memorized name. That's process logic, not pattern recall.</a:t>
+              <a:t>0.998 next-OPERATION accuracy — it predicts the right kind of step (deposit / etch / clean), not just a memorized name. That's process logic, not pattern recall.</a:t>
             </a:r>
           </a:p>
         </p:txBody>
@@ -8162,7 +8162,7 @@
                 </a:solidFill>
                 <a:latin typeface="Arial"/>
               </a:rPr>
-              <a:t>The learned anomaly encoder alone is ~chance (AUC 0.61); the physics hybrid supplies the exact in-distribution verdict. We show both numbers, not just the flattering one.</a:t>
+              <a:t>The learned anomaly encoder alone is ~chance (AUC 0.49); the physics hybrid supplies the exact verdict (F1 1.0, rule-attr 0.97). We show both, not just the flattering one.</a:t>
             </a:r>
           </a:p>
         </p:txBody>

</xml_diff>